<commit_message>
vault backup: 2026-10-19 00:58:53
</commit_message>
<xml_diff>
--- a/.build_behavior/candidate.pptx
+++ b/.build_behavior/candidate.pptx
@@ -2,13 +2,13 @@
 <file path=ppt/presentation.xml><?xml version="1.0" encoding="utf-8"?>
 <p:presentation xmlns:p="http://schemas.openxmlformats.org/presentationml/2006/main">
   <p:sldMasterIdLst>
-    <p:sldMasterId xmlns:r="http://schemas.openxmlformats.org/officeDocument/2006/relationships" id="2147483648" r:id="R719e4ea273114db9"/>
+    <p:sldMasterId xmlns:r="http://schemas.openxmlformats.org/officeDocument/2006/relationships" id="2147483648" r:id="R3ec6dd471faf4370"/>
   </p:sldMasterIdLst>
   <p:notesMasterIdLst>
-    <p:notesMasterId xmlns:r="http://schemas.openxmlformats.org/officeDocument/2006/relationships" r:id="Rafc515d0ae394fb4"/>
+    <p:notesMasterId xmlns:r="http://schemas.openxmlformats.org/officeDocument/2006/relationships" r:id="R3a34976f00b74066"/>
   </p:notesMasterIdLst>
   <p:sldIdLst>
-    <p:sldId xmlns:r="http://schemas.openxmlformats.org/officeDocument/2006/relationships" id="256" r:id="R239a642672e84111"/>
+    <p:sldId xmlns:r="http://schemas.openxmlformats.org/officeDocument/2006/relationships" id="256" r:id="R0e92debce49b4722"/>
   </p:sldIdLst>
   <p:sldSz cx="12192000" cy="6858000"/>
   <p:notesSz cx="6858000" cy="9144000"/>
@@ -519,7 +519,7 @@
           <p:cNvPr id="3" name="Title">
             <a:extLst xmlns:a="http://schemas.openxmlformats.org/drawingml/2006/main">
               <a:ext uri="{FF2B5EF4-FFF2-40B4-BE49-F238E27FC236}">
-                <a16:creationId xmlns:a16="http://schemas.microsoft.com/office/drawing/2014/main" id="{5DDBD214-B6AF-4DC1-847C-A7EF3ED5DC5E}"/>
+                <a16:creationId xmlns:a16="http://schemas.microsoft.com/office/drawing/2014/main" id="{B775237C-6EB6-490F-A0BF-3D7CABA27115}"/>
               </a:ext>
             </a:extLst>
           </p:cNvPr>
@@ -748,7 +748,7 @@
           <p:cNvPr id="2" name="Subtitle">
             <a:extLst xmlns:a="http://schemas.openxmlformats.org/drawingml/2006/main">
               <a:ext uri="{FF2B5EF4-FFF2-40B4-BE49-F238E27FC236}">
-                <a16:creationId xmlns:a16="http://schemas.microsoft.com/office/drawing/2014/main" id="{0825666B-09DD-4C33-898D-713CAE5C57CE}"/>
+                <a16:creationId xmlns:a16="http://schemas.microsoft.com/office/drawing/2014/main" id="{B002D470-EE45-4385-AD5D-5AD24DAC071C}"/>
               </a:ext>
             </a:extLst>
           </p:cNvPr>
@@ -994,7 +994,7 @@
           <p:cNvPr id="2" name="Section title">
             <a:extLst xmlns:a="http://schemas.openxmlformats.org/drawingml/2006/main">
               <a:ext uri="{FF2B5EF4-FFF2-40B4-BE49-F238E27FC236}">
-                <a16:creationId xmlns:a16="http://schemas.microsoft.com/office/drawing/2014/main" id="{A4312780-CEE6-4E97-B3E7-2D0DE8C391C4}"/>
+                <a16:creationId xmlns:a16="http://schemas.microsoft.com/office/drawing/2014/main" id="{530A02A2-B9EF-45BE-BD1D-4744BBD730E1}"/>
               </a:ext>
             </a:extLst>
           </p:cNvPr>
@@ -1240,7 +1240,7 @@
           <p:cNvPr id="3" name="Title">
             <a:extLst xmlns:a="http://schemas.openxmlformats.org/drawingml/2006/main">
               <a:ext uri="{FF2B5EF4-FFF2-40B4-BE49-F238E27FC236}">
-                <a16:creationId xmlns:a16="http://schemas.microsoft.com/office/drawing/2014/main" id="{854109B8-8A54-44DB-93FF-5353033E6180}"/>
+                <a16:creationId xmlns:a16="http://schemas.microsoft.com/office/drawing/2014/main" id="{3AA13D73-4754-4C14-933A-B47AB23C523B}"/>
               </a:ext>
             </a:extLst>
           </p:cNvPr>
@@ -1469,7 +1469,7 @@
           <p:cNvPr id="2" name="Body">
             <a:extLst xmlns:a="http://schemas.openxmlformats.org/drawingml/2006/main">
               <a:ext uri="{FF2B5EF4-FFF2-40B4-BE49-F238E27FC236}">
-                <a16:creationId xmlns:a16="http://schemas.microsoft.com/office/drawing/2014/main" id="{6A5C10EE-1656-4BF5-A8C2-D558B05D09B1}"/>
+                <a16:creationId xmlns:a16="http://schemas.microsoft.com/office/drawing/2014/main" id="{BC5CED43-E39A-496C-82CF-842BF7D4CEBB}"/>
               </a:ext>
             </a:extLst>
           </p:cNvPr>
@@ -1715,7 +1715,7 @@
           <p:cNvPr id="4" name="Title">
             <a:extLst xmlns:a="http://schemas.openxmlformats.org/drawingml/2006/main">
               <a:ext uri="{FF2B5EF4-FFF2-40B4-BE49-F238E27FC236}">
-                <a16:creationId xmlns:a16="http://schemas.microsoft.com/office/drawing/2014/main" id="{AAB5676C-DAD9-4751-A5B8-B8C5B679F094}"/>
+                <a16:creationId xmlns:a16="http://schemas.microsoft.com/office/drawing/2014/main" id="{9E16C6D1-C196-455C-8DB4-29BC3FDA5171}"/>
               </a:ext>
             </a:extLst>
           </p:cNvPr>
@@ -1944,7 +1944,7 @@
           <p:cNvPr id="2" name="Left column">
             <a:extLst xmlns:a="http://schemas.openxmlformats.org/drawingml/2006/main">
               <a:ext uri="{FF2B5EF4-FFF2-40B4-BE49-F238E27FC236}">
-                <a16:creationId xmlns:a16="http://schemas.microsoft.com/office/drawing/2014/main" id="{13020216-5F5E-4CA6-9E8A-32D7CF3715CD}"/>
+                <a16:creationId xmlns:a16="http://schemas.microsoft.com/office/drawing/2014/main" id="{5BF72D37-5C86-47C9-9430-C2846A989895}"/>
               </a:ext>
             </a:extLst>
           </p:cNvPr>
@@ -2173,7 +2173,7 @@
           <p:cNvPr id="3" name="Right column">
             <a:extLst xmlns:a="http://schemas.openxmlformats.org/drawingml/2006/main">
               <a:ext uri="{FF2B5EF4-FFF2-40B4-BE49-F238E27FC236}">
-                <a16:creationId xmlns:a16="http://schemas.microsoft.com/office/drawing/2014/main" id="{402165BC-6588-4CE3-8016-3CAF89E5B05C}"/>
+                <a16:creationId xmlns:a16="http://schemas.microsoft.com/office/drawing/2014/main" id="{A7323EF3-CEC0-427C-95D9-CE3D6FA14B33}"/>
               </a:ext>
             </a:extLst>
           </p:cNvPr>
@@ -2419,7 +2419,7 @@
           <p:cNvPr id="3" name="Title">
             <a:extLst xmlns:a="http://schemas.openxmlformats.org/drawingml/2006/main">
               <a:ext uri="{FF2B5EF4-FFF2-40B4-BE49-F238E27FC236}">
-                <a16:creationId xmlns:a16="http://schemas.microsoft.com/office/drawing/2014/main" id="{3674DED1-91D5-4EF6-B6D1-4AE8DF7EF776}"/>
+                <a16:creationId xmlns:a16="http://schemas.microsoft.com/office/drawing/2014/main" id="{04631089-E3EA-456B-87C3-578810EC19C5}"/>
               </a:ext>
             </a:extLst>
           </p:cNvPr>
@@ -2648,7 +2648,7 @@
           <p:cNvPr id="2" name="Left column">
             <a:extLst xmlns:a="http://schemas.openxmlformats.org/drawingml/2006/main">
               <a:ext uri="{FF2B5EF4-FFF2-40B4-BE49-F238E27FC236}">
-                <a16:creationId xmlns:a16="http://schemas.microsoft.com/office/drawing/2014/main" id="{90A3F669-6828-45BC-8030-998A6C6B6B13}"/>
+                <a16:creationId xmlns:a16="http://schemas.microsoft.com/office/drawing/2014/main" id="{F2E59759-E50C-457F-9036-C2DC1535A7C0}"/>
               </a:ext>
             </a:extLst>
           </p:cNvPr>
@@ -2915,12 +2915,12 @@
   </p:cSld>
   <p:clrMap bg1="lt1" tx1="dk1" bg2="lt2" tx2="dk2" accent1="accent1" accent2="accent2" accent3="accent3" accent4="accent4" accent5="accent5" accent6="accent6" hlink="hlink" folHlink="folHlink"/>
   <p:sldLayoutIdLst>
-    <p:sldLayoutId xmlns:r="http://schemas.openxmlformats.org/officeDocument/2006/relationships" id="2147483649" r:id="Rc4141b4834e14846"/>
-    <p:sldLayoutId xmlns:r="http://schemas.openxmlformats.org/officeDocument/2006/relationships" id="2147483650" r:id="R2120b422b43a4507"/>
-    <p:sldLayoutId xmlns:r="http://schemas.openxmlformats.org/officeDocument/2006/relationships" id="2147483651" r:id="Rde881fb344564c17"/>
-    <p:sldLayoutId xmlns:r="http://schemas.openxmlformats.org/officeDocument/2006/relationships" id="2147483652" r:id="Re69ab1c51ef0477a"/>
-    <p:sldLayoutId xmlns:r="http://schemas.openxmlformats.org/officeDocument/2006/relationships" id="2147483653" r:id="R1f5a23da90a6477e"/>
-    <p:sldLayoutId xmlns:r="http://schemas.openxmlformats.org/officeDocument/2006/relationships" id="2147483654" r:id="Rb7ed5b0d690f4f19"/>
+    <p:sldLayoutId xmlns:r="http://schemas.openxmlformats.org/officeDocument/2006/relationships" id="2147483649" r:id="R515a7189b21b4874"/>
+    <p:sldLayoutId xmlns:r="http://schemas.openxmlformats.org/officeDocument/2006/relationships" id="2147483650" r:id="R02bd8762f57246e0"/>
+    <p:sldLayoutId xmlns:r="http://schemas.openxmlformats.org/officeDocument/2006/relationships" id="2147483651" r:id="R6c791ed716644faf"/>
+    <p:sldLayoutId xmlns:r="http://schemas.openxmlformats.org/officeDocument/2006/relationships" id="2147483652" r:id="Re42d9efa495d411e"/>
+    <p:sldLayoutId xmlns:r="http://schemas.openxmlformats.org/officeDocument/2006/relationships" id="2147483653" r:id="Rbc204ee3ba904ddf"/>
+    <p:sldLayoutId xmlns:r="http://schemas.openxmlformats.org/officeDocument/2006/relationships" id="2147483654" r:id="R3f9617f682974dfe"/>
   </p:sldLayoutIdLst>
   <p:txStyles>
     <p:titleStyle>
@@ -3471,7 +3471,7 @@
           <p:cNvPr id="10" name="">
             <a:extLst xmlns:a="http://schemas.openxmlformats.org/drawingml/2006/main">
               <a:ext uri="{FF2B5EF4-FFF2-40B4-BE49-F238E27FC236}">
-                <a16:creationId xmlns:a16="http://schemas.microsoft.com/office/drawing/2014/main" id="{85581CFB-7B37-4377-BAA3-AD1BBADFFA94}"/>
+                <a16:creationId xmlns:a16="http://schemas.microsoft.com/office/drawing/2014/main" id="{65967D8A-B2A1-42C2-9F19-2CE275615E42}"/>
               </a:ext>
             </a:extLst>
           </p:cNvPr>
@@ -3501,6 +3501,9 @@
                 <a:solidFill>
                   <a:srgbClr val="172D42"/>
                 </a:solidFill>
+                <a:latin typeface="Yu Gothic"/>
+                <a:ea typeface="Yu Gothic"/>
+                <a:cs typeface="Yu Gothic"/>
               </a:defRPr>
             </a:defPPr>
             <a:lvl1pPr>
@@ -3508,6 +3511,9 @@
                 <a:solidFill>
                   <a:srgbClr val="172D42"/>
                 </a:solidFill>
+                <a:latin typeface="Yu Gothic"/>
+                <a:ea typeface="Yu Gothic"/>
+                <a:cs typeface="Yu Gothic"/>
               </a:defRPr>
             </a:lvl1pPr>
             <a:lvl2pPr>
@@ -3515,6 +3521,9 @@
                 <a:solidFill>
                   <a:srgbClr val="172D42"/>
                 </a:solidFill>
+                <a:latin typeface="Yu Gothic"/>
+                <a:ea typeface="Yu Gothic"/>
+                <a:cs typeface="Yu Gothic"/>
               </a:defRPr>
             </a:lvl2pPr>
             <a:lvl3pPr>
@@ -3522,6 +3531,9 @@
                 <a:solidFill>
                   <a:srgbClr val="172D42"/>
                 </a:solidFill>
+                <a:latin typeface="Yu Gothic"/>
+                <a:ea typeface="Yu Gothic"/>
+                <a:cs typeface="Yu Gothic"/>
               </a:defRPr>
             </a:lvl3pPr>
             <a:lvl4pPr>
@@ -3529,6 +3541,9 @@
                 <a:solidFill>
                   <a:srgbClr val="172D42"/>
                 </a:solidFill>
+                <a:latin typeface="Yu Gothic"/>
+                <a:ea typeface="Yu Gothic"/>
+                <a:cs typeface="Yu Gothic"/>
               </a:defRPr>
             </a:lvl4pPr>
             <a:lvl5pPr>
@@ -3536,6 +3551,9 @@
                 <a:solidFill>
                   <a:srgbClr val="172D42"/>
                 </a:solidFill>
+                <a:latin typeface="Yu Gothic"/>
+                <a:ea typeface="Yu Gothic"/>
+                <a:cs typeface="Yu Gothic"/>
               </a:defRPr>
             </a:lvl5pPr>
             <a:lvl6pPr>
@@ -3543,6 +3561,9 @@
                 <a:solidFill>
                   <a:srgbClr val="172D42"/>
                 </a:solidFill>
+                <a:latin typeface="Yu Gothic"/>
+                <a:ea typeface="Yu Gothic"/>
+                <a:cs typeface="Yu Gothic"/>
               </a:defRPr>
             </a:lvl6pPr>
             <a:lvl7pPr>
@@ -3550,6 +3571,9 @@
                 <a:solidFill>
                   <a:srgbClr val="172D42"/>
                 </a:solidFill>
+                <a:latin typeface="Yu Gothic"/>
+                <a:ea typeface="Yu Gothic"/>
+                <a:cs typeface="Yu Gothic"/>
               </a:defRPr>
             </a:lvl7pPr>
             <a:lvl8pPr>
@@ -3557,6 +3581,9 @@
                 <a:solidFill>
                   <a:srgbClr val="172D42"/>
                 </a:solidFill>
+                <a:latin typeface="Yu Gothic"/>
+                <a:ea typeface="Yu Gothic"/>
+                <a:cs typeface="Yu Gothic"/>
               </a:defRPr>
             </a:lvl8pPr>
             <a:lvl9pPr>
@@ -3564,6 +3591,9 @@
                 <a:solidFill>
                   <a:srgbClr val="172D42"/>
                 </a:solidFill>
+                <a:latin typeface="Yu Gothic"/>
+                <a:ea typeface="Yu Gothic"/>
+                <a:cs typeface="Yu Gothic"/>
               </a:defRPr>
             </a:lvl9pPr>
           </a:lstStyle>
@@ -3573,6 +3603,9 @@
                 <a:solidFill>
                   <a:srgbClr val="172D42"/>
                 </a:solidFill>
+                <a:latin typeface="Yu Gothic"/>
+                <a:ea typeface="Yu Gothic"/>
+                <a:cs typeface="Yu Gothic"/>
               </a:defRPr>
             </a:pPr>
             <a:r>
@@ -3580,6 +3613,9 @@
                 <a:solidFill>
                   <a:srgbClr val="172D42"/>
                 </a:solidFill>
+                <a:latin typeface="Yu Gothic"/>
+                <a:ea typeface="Yu Gothic"/>
+                <a:cs typeface="Yu Gothic"/>
               </a:rPr>
               <a:t>Behavior Retrieval</a:t>
             </a:r>
@@ -3591,7 +3627,7 @@
           <p:cNvPr id="2" name="">
             <a:extLst xmlns:a="http://schemas.openxmlformats.org/drawingml/2006/main">
               <a:ext uri="{FF2B5EF4-FFF2-40B4-BE49-F238E27FC236}">
-                <a16:creationId xmlns:a16="http://schemas.microsoft.com/office/drawing/2014/main" id="{57833E00-D83E-47ED-9FC4-1B2087BED40F}"/>
+                <a16:creationId xmlns:a16="http://schemas.microsoft.com/office/drawing/2014/main" id="{407C08DB-7A9A-4B0A-B30F-6858009E5B54}"/>
               </a:ext>
             </a:extLst>
           </p:cNvPr>
@@ -3621,6 +3657,9 @@
                 <a:solidFill>
                   <a:srgbClr val="172D42"/>
                 </a:solidFill>
+                <a:latin typeface="Yu Gothic"/>
+                <a:ea typeface="Yu Gothic"/>
+                <a:cs typeface="Yu Gothic"/>
               </a:defRPr>
             </a:defPPr>
             <a:lvl1pPr>
@@ -3628,6 +3667,9 @@
                 <a:solidFill>
                   <a:srgbClr val="172D42"/>
                 </a:solidFill>
+                <a:latin typeface="Yu Gothic"/>
+                <a:ea typeface="Yu Gothic"/>
+                <a:cs typeface="Yu Gothic"/>
               </a:defRPr>
             </a:lvl1pPr>
             <a:lvl2pPr>
@@ -3635,6 +3677,9 @@
                 <a:solidFill>
                   <a:srgbClr val="172D42"/>
                 </a:solidFill>
+                <a:latin typeface="Yu Gothic"/>
+                <a:ea typeface="Yu Gothic"/>
+                <a:cs typeface="Yu Gothic"/>
               </a:defRPr>
             </a:lvl2pPr>
             <a:lvl3pPr>
@@ -3642,6 +3687,9 @@
                 <a:solidFill>
                   <a:srgbClr val="172D42"/>
                 </a:solidFill>
+                <a:latin typeface="Yu Gothic"/>
+                <a:ea typeface="Yu Gothic"/>
+                <a:cs typeface="Yu Gothic"/>
               </a:defRPr>
             </a:lvl3pPr>
             <a:lvl4pPr>
@@ -3649,6 +3697,9 @@
                 <a:solidFill>
                   <a:srgbClr val="172D42"/>
                 </a:solidFill>
+                <a:latin typeface="Yu Gothic"/>
+                <a:ea typeface="Yu Gothic"/>
+                <a:cs typeface="Yu Gothic"/>
               </a:defRPr>
             </a:lvl4pPr>
             <a:lvl5pPr>
@@ -3656,6 +3707,9 @@
                 <a:solidFill>
                   <a:srgbClr val="172D42"/>
                 </a:solidFill>
+                <a:latin typeface="Yu Gothic"/>
+                <a:ea typeface="Yu Gothic"/>
+                <a:cs typeface="Yu Gothic"/>
               </a:defRPr>
             </a:lvl5pPr>
             <a:lvl6pPr>
@@ -3663,6 +3717,9 @@
                 <a:solidFill>
                   <a:srgbClr val="172D42"/>
                 </a:solidFill>
+                <a:latin typeface="Yu Gothic"/>
+                <a:ea typeface="Yu Gothic"/>
+                <a:cs typeface="Yu Gothic"/>
               </a:defRPr>
             </a:lvl6pPr>
             <a:lvl7pPr>
@@ -3670,6 +3727,9 @@
                 <a:solidFill>
                   <a:srgbClr val="172D42"/>
                 </a:solidFill>
+                <a:latin typeface="Yu Gothic"/>
+                <a:ea typeface="Yu Gothic"/>
+                <a:cs typeface="Yu Gothic"/>
               </a:defRPr>
             </a:lvl7pPr>
             <a:lvl8pPr>
@@ -3677,6 +3737,9 @@
                 <a:solidFill>
                   <a:srgbClr val="172D42"/>
                 </a:solidFill>
+                <a:latin typeface="Yu Gothic"/>
+                <a:ea typeface="Yu Gothic"/>
+                <a:cs typeface="Yu Gothic"/>
               </a:defRPr>
             </a:lvl8pPr>
             <a:lvl9pPr>
@@ -3684,6 +3747,9 @@
                 <a:solidFill>
                   <a:srgbClr val="172D42"/>
                 </a:solidFill>
+                <a:latin typeface="Yu Gothic"/>
+                <a:ea typeface="Yu Gothic"/>
+                <a:cs typeface="Yu Gothic"/>
               </a:defRPr>
             </a:lvl9pPr>
           </a:lstStyle>
@@ -3693,6 +3759,9 @@
                 <a:solidFill>
                   <a:srgbClr val="172D42"/>
                 </a:solidFill>
+                <a:latin typeface="Yu Gothic"/>
+                <a:ea typeface="Yu Gothic"/>
+                <a:cs typeface="Yu Gothic"/>
               </a:defRPr>
             </a:pPr>
             <a:r>
@@ -3700,6 +3769,9 @@
                 <a:solidFill>
                   <a:srgbClr val="172D42"/>
                 </a:solidFill>
+                <a:latin typeface="Yu Gothic"/>
+                <a:ea typeface="Yu Gothic"/>
+                <a:cs typeface="Yu Gothic"/>
               </a:rPr>
               <a:t>少数デモを手がかりにした学習データ選択</a:t>
             </a:r>
@@ -3711,7 +3783,7 @@
           <p:cNvPr id="3" name="">
             <a:extLst xmlns:a="http://schemas.openxmlformats.org/drawingml/2006/main">
               <a:ext uri="{FF2B5EF4-FFF2-40B4-BE49-F238E27FC236}">
-                <a16:creationId xmlns:a16="http://schemas.microsoft.com/office/drawing/2014/main" id="{51E78327-8E94-4C54-BAC3-26FB0609D7AB}"/>
+                <a16:creationId xmlns:a16="http://schemas.microsoft.com/office/drawing/2014/main" id="{7020CCB9-2214-4549-A678-4B95E651FCAB}"/>
               </a:ext>
             </a:extLst>
           </p:cNvPr>
@@ -3741,6 +3813,9 @@
                 <a:solidFill>
                   <a:srgbClr val="172D42"/>
                 </a:solidFill>
+                <a:latin typeface="Yu Gothic"/>
+                <a:ea typeface="Yu Gothic"/>
+                <a:cs typeface="Yu Gothic"/>
               </a:defRPr>
             </a:defPPr>
             <a:lvl1pPr>
@@ -3748,6 +3823,9 @@
                 <a:solidFill>
                   <a:srgbClr val="172D42"/>
                 </a:solidFill>
+                <a:latin typeface="Yu Gothic"/>
+                <a:ea typeface="Yu Gothic"/>
+                <a:cs typeface="Yu Gothic"/>
               </a:defRPr>
             </a:lvl1pPr>
             <a:lvl2pPr>
@@ -3755,6 +3833,9 @@
                 <a:solidFill>
                   <a:srgbClr val="172D42"/>
                 </a:solidFill>
+                <a:latin typeface="Yu Gothic"/>
+                <a:ea typeface="Yu Gothic"/>
+                <a:cs typeface="Yu Gothic"/>
               </a:defRPr>
             </a:lvl2pPr>
             <a:lvl3pPr>
@@ -3762,6 +3843,9 @@
                 <a:solidFill>
                   <a:srgbClr val="172D42"/>
                 </a:solidFill>
+                <a:latin typeface="Yu Gothic"/>
+                <a:ea typeface="Yu Gothic"/>
+                <a:cs typeface="Yu Gothic"/>
               </a:defRPr>
             </a:lvl3pPr>
             <a:lvl4pPr>
@@ -3769,6 +3853,9 @@
                 <a:solidFill>
                   <a:srgbClr val="172D42"/>
                 </a:solidFill>
+                <a:latin typeface="Yu Gothic"/>
+                <a:ea typeface="Yu Gothic"/>
+                <a:cs typeface="Yu Gothic"/>
               </a:defRPr>
             </a:lvl4pPr>
             <a:lvl5pPr>
@@ -3776,6 +3863,9 @@
                 <a:solidFill>
                   <a:srgbClr val="172D42"/>
                 </a:solidFill>
+                <a:latin typeface="Yu Gothic"/>
+                <a:ea typeface="Yu Gothic"/>
+                <a:cs typeface="Yu Gothic"/>
               </a:defRPr>
             </a:lvl5pPr>
             <a:lvl6pPr>
@@ -3783,6 +3873,9 @@
                 <a:solidFill>
                   <a:srgbClr val="172D42"/>
                 </a:solidFill>
+                <a:latin typeface="Yu Gothic"/>
+                <a:ea typeface="Yu Gothic"/>
+                <a:cs typeface="Yu Gothic"/>
               </a:defRPr>
             </a:lvl6pPr>
             <a:lvl7pPr>
@@ -3790,6 +3883,9 @@
                 <a:solidFill>
                   <a:srgbClr val="172D42"/>
                 </a:solidFill>
+                <a:latin typeface="Yu Gothic"/>
+                <a:ea typeface="Yu Gothic"/>
+                <a:cs typeface="Yu Gothic"/>
               </a:defRPr>
             </a:lvl7pPr>
             <a:lvl8pPr>
@@ -3797,6 +3893,9 @@
                 <a:solidFill>
                   <a:srgbClr val="172D42"/>
                 </a:solidFill>
+                <a:latin typeface="Yu Gothic"/>
+                <a:ea typeface="Yu Gothic"/>
+                <a:cs typeface="Yu Gothic"/>
               </a:defRPr>
             </a:lvl8pPr>
             <a:lvl9pPr>
@@ -3804,6 +3903,9 @@
                 <a:solidFill>
                   <a:srgbClr val="172D42"/>
                 </a:solidFill>
+                <a:latin typeface="Yu Gothic"/>
+                <a:ea typeface="Yu Gothic"/>
+                <a:cs typeface="Yu Gothic"/>
               </a:defRPr>
             </a:lvl9pPr>
           </a:lstStyle>
@@ -3813,6 +3915,9 @@
                 <a:solidFill>
                   <a:srgbClr val="172D42"/>
                 </a:solidFill>
+                <a:latin typeface="Yu Gothic"/>
+                <a:ea typeface="Yu Gothic"/>
+                <a:cs typeface="Yu Gothic"/>
               </a:defRPr>
             </a:pPr>
             <a:r>
@@ -3820,6 +3925,9 @@
                 <a:solidFill>
                   <a:srgbClr val="172D42"/>
                 </a:solidFill>
+                <a:latin typeface="Yu Gothic"/>
+                <a:ea typeface="Yu Gothic"/>
+                <a:cs typeface="Yu Gothic"/>
               </a:rPr>
               <a:t>既存の状態・行動</a:t>
             </a:r>
@@ -3831,7 +3939,7 @@
           <p:cNvPr id="4" name="">
             <a:extLst xmlns:a="http://schemas.openxmlformats.org/drawingml/2006/main">
               <a:ext uri="{FF2B5EF4-FFF2-40B4-BE49-F238E27FC236}">
-                <a16:creationId xmlns:a16="http://schemas.microsoft.com/office/drawing/2014/main" id="{0D1ECE4C-D437-4019-97F9-A77A82D8F5E5}"/>
+                <a16:creationId xmlns:a16="http://schemas.microsoft.com/office/drawing/2014/main" id="{17D07F38-96D7-471E-8FD7-AF3A5F3D680D}"/>
               </a:ext>
             </a:extLst>
           </p:cNvPr>
@@ -3861,6 +3969,9 @@
                 <a:solidFill>
                   <a:srgbClr val="008C95"/>
                 </a:solidFill>
+                <a:latin typeface="Yu Gothic"/>
+                <a:ea typeface="Yu Gothic"/>
+                <a:cs typeface="Yu Gothic"/>
               </a:defRPr>
             </a:defPPr>
             <a:lvl1pPr>
@@ -3868,6 +3979,9 @@
                 <a:solidFill>
                   <a:srgbClr val="008C95"/>
                 </a:solidFill>
+                <a:latin typeface="Yu Gothic"/>
+                <a:ea typeface="Yu Gothic"/>
+                <a:cs typeface="Yu Gothic"/>
               </a:defRPr>
             </a:lvl1pPr>
             <a:lvl2pPr>
@@ -3875,6 +3989,9 @@
                 <a:solidFill>
                   <a:srgbClr val="008C95"/>
                 </a:solidFill>
+                <a:latin typeface="Yu Gothic"/>
+                <a:ea typeface="Yu Gothic"/>
+                <a:cs typeface="Yu Gothic"/>
               </a:defRPr>
             </a:lvl2pPr>
             <a:lvl3pPr>
@@ -3882,6 +3999,9 @@
                 <a:solidFill>
                   <a:srgbClr val="008C95"/>
                 </a:solidFill>
+                <a:latin typeface="Yu Gothic"/>
+                <a:ea typeface="Yu Gothic"/>
+                <a:cs typeface="Yu Gothic"/>
               </a:defRPr>
             </a:lvl3pPr>
             <a:lvl4pPr>
@@ -3889,6 +4009,9 @@
                 <a:solidFill>
                   <a:srgbClr val="008C95"/>
                 </a:solidFill>
+                <a:latin typeface="Yu Gothic"/>
+                <a:ea typeface="Yu Gothic"/>
+                <a:cs typeface="Yu Gothic"/>
               </a:defRPr>
             </a:lvl4pPr>
             <a:lvl5pPr>
@@ -3896,6 +4019,9 @@
                 <a:solidFill>
                   <a:srgbClr val="008C95"/>
                 </a:solidFill>
+                <a:latin typeface="Yu Gothic"/>
+                <a:ea typeface="Yu Gothic"/>
+                <a:cs typeface="Yu Gothic"/>
               </a:defRPr>
             </a:lvl5pPr>
             <a:lvl6pPr>
@@ -3903,6 +4029,9 @@
                 <a:solidFill>
                   <a:srgbClr val="008C95"/>
                 </a:solidFill>
+                <a:latin typeface="Yu Gothic"/>
+                <a:ea typeface="Yu Gothic"/>
+                <a:cs typeface="Yu Gothic"/>
               </a:defRPr>
             </a:lvl6pPr>
             <a:lvl7pPr>
@@ -3910,6 +4039,9 @@
                 <a:solidFill>
                   <a:srgbClr val="008C95"/>
                 </a:solidFill>
+                <a:latin typeface="Yu Gothic"/>
+                <a:ea typeface="Yu Gothic"/>
+                <a:cs typeface="Yu Gothic"/>
               </a:defRPr>
             </a:lvl7pPr>
             <a:lvl8pPr>
@@ -3917,6 +4049,9 @@
                 <a:solidFill>
                   <a:srgbClr val="008C95"/>
                 </a:solidFill>
+                <a:latin typeface="Yu Gothic"/>
+                <a:ea typeface="Yu Gothic"/>
+                <a:cs typeface="Yu Gothic"/>
               </a:defRPr>
             </a:lvl8pPr>
             <a:lvl9pPr>
@@ -3924,6 +4059,9 @@
                 <a:solidFill>
                   <a:srgbClr val="008C95"/>
                 </a:solidFill>
+                <a:latin typeface="Yu Gothic"/>
+                <a:ea typeface="Yu Gothic"/>
+                <a:cs typeface="Yu Gothic"/>
               </a:defRPr>
             </a:lvl9pPr>
           </a:lstStyle>
@@ -3933,6 +4071,9 @@
                 <a:solidFill>
                   <a:srgbClr val="008C95"/>
                 </a:solidFill>
+                <a:latin typeface="Yu Gothic"/>
+                <a:ea typeface="Yu Gothic"/>
+                <a:cs typeface="Yu Gothic"/>
               </a:defRPr>
             </a:pPr>
             <a:r>
@@ -3940,6 +4081,9 @@
                 <a:solidFill>
                   <a:srgbClr val="008C95"/>
                 </a:solidFill>
+                <a:latin typeface="Yu Gothic"/>
+                <a:ea typeface="Yu Gothic"/>
+                <a:cs typeface="Yu Gothic"/>
               </a:rPr>
               <a:t>少数の対象デモ</a:t>
             </a:r>
@@ -3951,7 +4095,7 @@
           <p:cNvPr id="5" name="">
             <a:extLst xmlns:a="http://schemas.openxmlformats.org/drawingml/2006/main">
               <a:ext uri="{FF2B5EF4-FFF2-40B4-BE49-F238E27FC236}">
-                <a16:creationId xmlns:a16="http://schemas.microsoft.com/office/drawing/2014/main" id="{1B0E93A7-5B73-4204-8B04-92379724A009}"/>
+                <a16:creationId xmlns:a16="http://schemas.microsoft.com/office/drawing/2014/main" id="{95BDF9AF-74CB-460F-A1CF-0B7E111D0997}"/>
               </a:ext>
             </a:extLst>
           </p:cNvPr>
@@ -3961,7 +4105,7 @@
           <p:nvPr/>
         </p:nvPicPr>
         <p:blipFill>
-          <a:blip xmlns:r="http://schemas.openxmlformats.org/officeDocument/2006/relationships" xmlns:a="http://schemas.openxmlformats.org/drawingml/2006/main" r:embed="Raf013f10e84f497c"/>
+          <a:blip xmlns:r="http://schemas.openxmlformats.org/officeDocument/2006/relationships" xmlns:a="http://schemas.openxmlformats.org/drawingml/2006/main" r:embed="Rd22d09e5f257452d"/>
           <a:stretch xmlns:a="http://schemas.openxmlformats.org/drawingml/2006/main"/>
         </p:blipFill>
         <p:spPr>
@@ -3979,7 +4123,7 @@
           <p:cNvPr id="6" name="">
             <a:extLst xmlns:a="http://schemas.openxmlformats.org/drawingml/2006/main">
               <a:ext uri="{FF2B5EF4-FFF2-40B4-BE49-F238E27FC236}">
-                <a16:creationId xmlns:a16="http://schemas.microsoft.com/office/drawing/2014/main" id="{67818C94-6463-4250-93A7-2292A804B605}"/>
+                <a16:creationId xmlns:a16="http://schemas.microsoft.com/office/drawing/2014/main" id="{90EFF5B3-4989-45EB-9BF2-A187DB581AE6}"/>
               </a:ext>
             </a:extLst>
           </p:cNvPr>
@@ -4009,6 +4153,9 @@
                 <a:solidFill>
                   <a:srgbClr val="172D42"/>
                 </a:solidFill>
+                <a:latin typeface="Yu Gothic"/>
+                <a:ea typeface="Yu Gothic"/>
+                <a:cs typeface="Yu Gothic"/>
               </a:defRPr>
             </a:defPPr>
             <a:lvl1pPr>
@@ -4016,6 +4163,9 @@
                 <a:solidFill>
                   <a:srgbClr val="172D42"/>
                 </a:solidFill>
+                <a:latin typeface="Yu Gothic"/>
+                <a:ea typeface="Yu Gothic"/>
+                <a:cs typeface="Yu Gothic"/>
               </a:defRPr>
             </a:lvl1pPr>
             <a:lvl2pPr>
@@ -4023,6 +4173,9 @@
                 <a:solidFill>
                   <a:srgbClr val="172D42"/>
                 </a:solidFill>
+                <a:latin typeface="Yu Gothic"/>
+                <a:ea typeface="Yu Gothic"/>
+                <a:cs typeface="Yu Gothic"/>
               </a:defRPr>
             </a:lvl2pPr>
             <a:lvl3pPr>
@@ -4030,6 +4183,9 @@
                 <a:solidFill>
                   <a:srgbClr val="172D42"/>
                 </a:solidFill>
+                <a:latin typeface="Yu Gothic"/>
+                <a:ea typeface="Yu Gothic"/>
+                <a:cs typeface="Yu Gothic"/>
               </a:defRPr>
             </a:lvl3pPr>
             <a:lvl4pPr>
@@ -4037,6 +4193,9 @@
                 <a:solidFill>
                   <a:srgbClr val="172D42"/>
                 </a:solidFill>
+                <a:latin typeface="Yu Gothic"/>
+                <a:ea typeface="Yu Gothic"/>
+                <a:cs typeface="Yu Gothic"/>
               </a:defRPr>
             </a:lvl4pPr>
             <a:lvl5pPr>
@@ -4044,6 +4203,9 @@
                 <a:solidFill>
                   <a:srgbClr val="172D42"/>
                 </a:solidFill>
+                <a:latin typeface="Yu Gothic"/>
+                <a:ea typeface="Yu Gothic"/>
+                <a:cs typeface="Yu Gothic"/>
               </a:defRPr>
             </a:lvl5pPr>
             <a:lvl6pPr>
@@ -4051,6 +4213,9 @@
                 <a:solidFill>
                   <a:srgbClr val="172D42"/>
                 </a:solidFill>
+                <a:latin typeface="Yu Gothic"/>
+                <a:ea typeface="Yu Gothic"/>
+                <a:cs typeface="Yu Gothic"/>
               </a:defRPr>
             </a:lvl6pPr>
             <a:lvl7pPr>
@@ -4058,6 +4223,9 @@
                 <a:solidFill>
                   <a:srgbClr val="172D42"/>
                 </a:solidFill>
+                <a:latin typeface="Yu Gothic"/>
+                <a:ea typeface="Yu Gothic"/>
+                <a:cs typeface="Yu Gothic"/>
               </a:defRPr>
             </a:lvl7pPr>
             <a:lvl8pPr>
@@ -4065,6 +4233,9 @@
                 <a:solidFill>
                   <a:srgbClr val="172D42"/>
                 </a:solidFill>
+                <a:latin typeface="Yu Gothic"/>
+                <a:ea typeface="Yu Gothic"/>
+                <a:cs typeface="Yu Gothic"/>
               </a:defRPr>
             </a:lvl8pPr>
             <a:lvl9pPr>
@@ -4072,6 +4243,9 @@
                 <a:solidFill>
                   <a:srgbClr val="172D42"/>
                 </a:solidFill>
+                <a:latin typeface="Yu Gothic"/>
+                <a:ea typeface="Yu Gothic"/>
+                <a:cs typeface="Yu Gothic"/>
               </a:defRPr>
             </a:lvl9pPr>
           </a:lstStyle>
@@ -4081,6 +4255,9 @@
                 <a:solidFill>
                   <a:srgbClr val="172D42"/>
                 </a:solidFill>
+                <a:latin typeface="Yu Gothic"/>
+                <a:ea typeface="Yu Gothic"/>
+                <a:cs typeface="Yu Gothic"/>
               </a:defRPr>
             </a:pPr>
             <a:r>
@@ -4088,6 +4265,9 @@
                 <a:solidFill>
                   <a:srgbClr val="172D42"/>
                 </a:solidFill>
+                <a:latin typeface="Yu Gothic"/>
+                <a:ea typeface="Yu Gothic"/>
+                <a:cs typeface="Yu Gothic"/>
               </a:rPr>
               <a:t>VAEによる埋め込み</a:t>
             </a:r>
@@ -4099,7 +4279,7 @@
           <p:cNvPr id="7" name="">
             <a:extLst xmlns:a="http://schemas.openxmlformats.org/drawingml/2006/main">
               <a:ext uri="{FF2B5EF4-FFF2-40B4-BE49-F238E27FC236}">
-                <a16:creationId xmlns:a16="http://schemas.microsoft.com/office/drawing/2014/main" id="{74635161-689A-4245-8411-59E29A9628A2}"/>
+                <a16:creationId xmlns:a16="http://schemas.microsoft.com/office/drawing/2014/main" id="{8453A13A-068F-4B7D-B90A-F01A8F224334}"/>
               </a:ext>
             </a:extLst>
           </p:cNvPr>
@@ -4129,6 +4309,9 @@
                 <a:solidFill>
                   <a:srgbClr val="008C95"/>
                 </a:solidFill>
+                <a:latin typeface="Yu Gothic"/>
+                <a:ea typeface="Yu Gothic"/>
+                <a:cs typeface="Yu Gothic"/>
               </a:defRPr>
             </a:defPPr>
             <a:lvl1pPr>
@@ -4136,6 +4319,9 @@
                 <a:solidFill>
                   <a:srgbClr val="008C95"/>
                 </a:solidFill>
+                <a:latin typeface="Yu Gothic"/>
+                <a:ea typeface="Yu Gothic"/>
+                <a:cs typeface="Yu Gothic"/>
               </a:defRPr>
             </a:lvl1pPr>
             <a:lvl2pPr>
@@ -4143,6 +4329,9 @@
                 <a:solidFill>
                   <a:srgbClr val="008C95"/>
                 </a:solidFill>
+                <a:latin typeface="Yu Gothic"/>
+                <a:ea typeface="Yu Gothic"/>
+                <a:cs typeface="Yu Gothic"/>
               </a:defRPr>
             </a:lvl2pPr>
             <a:lvl3pPr>
@@ -4150,6 +4339,9 @@
                 <a:solidFill>
                   <a:srgbClr val="008C95"/>
                 </a:solidFill>
+                <a:latin typeface="Yu Gothic"/>
+                <a:ea typeface="Yu Gothic"/>
+                <a:cs typeface="Yu Gothic"/>
               </a:defRPr>
             </a:lvl3pPr>
             <a:lvl4pPr>
@@ -4157,6 +4349,9 @@
                 <a:solidFill>
                   <a:srgbClr val="008C95"/>
                 </a:solidFill>
+                <a:latin typeface="Yu Gothic"/>
+                <a:ea typeface="Yu Gothic"/>
+                <a:cs typeface="Yu Gothic"/>
               </a:defRPr>
             </a:lvl4pPr>
             <a:lvl5pPr>
@@ -4164,6 +4359,9 @@
                 <a:solidFill>
                   <a:srgbClr val="008C95"/>
                 </a:solidFill>
+                <a:latin typeface="Yu Gothic"/>
+                <a:ea typeface="Yu Gothic"/>
+                <a:cs typeface="Yu Gothic"/>
               </a:defRPr>
             </a:lvl5pPr>
             <a:lvl6pPr>
@@ -4171,6 +4369,9 @@
                 <a:solidFill>
                   <a:srgbClr val="008C95"/>
                 </a:solidFill>
+                <a:latin typeface="Yu Gothic"/>
+                <a:ea typeface="Yu Gothic"/>
+                <a:cs typeface="Yu Gothic"/>
               </a:defRPr>
             </a:lvl6pPr>
             <a:lvl7pPr>
@@ -4178,6 +4379,9 @@
                 <a:solidFill>
                   <a:srgbClr val="008C95"/>
                 </a:solidFill>
+                <a:latin typeface="Yu Gothic"/>
+                <a:ea typeface="Yu Gothic"/>
+                <a:cs typeface="Yu Gothic"/>
               </a:defRPr>
             </a:lvl7pPr>
             <a:lvl8pPr>
@@ -4185,6 +4389,9 @@
                 <a:solidFill>
                   <a:srgbClr val="008C95"/>
                 </a:solidFill>
+                <a:latin typeface="Yu Gothic"/>
+                <a:ea typeface="Yu Gothic"/>
+                <a:cs typeface="Yu Gothic"/>
               </a:defRPr>
             </a:lvl8pPr>
             <a:lvl9pPr>
@@ -4192,6 +4399,9 @@
                 <a:solidFill>
                   <a:srgbClr val="008C95"/>
                 </a:solidFill>
+                <a:latin typeface="Yu Gothic"/>
+                <a:ea typeface="Yu Gothic"/>
+                <a:cs typeface="Yu Gothic"/>
               </a:defRPr>
             </a:lvl9pPr>
           </a:lstStyle>
@@ -4201,6 +4411,9 @@
                 <a:solidFill>
                   <a:srgbClr val="008C95"/>
                 </a:solidFill>
+                <a:latin typeface="Yu Gothic"/>
+                <a:ea typeface="Yu Gothic"/>
+                <a:cs typeface="Yu Gothic"/>
               </a:defRPr>
             </a:pPr>
             <a:r>
@@ -4208,6 +4421,9 @@
                 <a:solidFill>
                   <a:srgbClr val="008C95"/>
                 </a:solidFill>
+                <a:latin typeface="Yu Gothic"/>
+                <a:ea typeface="Yu Gothic"/>
+                <a:cs typeface="Yu Gothic"/>
               </a:rPr>
               <a:t>L2距離・閾値選択</a:t>
             </a:r>
@@ -4219,7 +4435,7 @@
           <p:cNvPr id="8" name="">
             <a:extLst xmlns:a="http://schemas.openxmlformats.org/drawingml/2006/main">
               <a:ext uri="{FF2B5EF4-FFF2-40B4-BE49-F238E27FC236}">
-                <a16:creationId xmlns:a16="http://schemas.microsoft.com/office/drawing/2014/main" id="{DFCE9E5F-8C87-426B-A018-25E49B41F9A3}"/>
+                <a16:creationId xmlns:a16="http://schemas.microsoft.com/office/drawing/2014/main" id="{AFCA58CF-73ED-49DD-8257-03954E30C9DA}"/>
               </a:ext>
             </a:extLst>
           </p:cNvPr>
@@ -4249,6 +4465,9 @@
                 <a:solidFill>
                   <a:srgbClr val="172D42"/>
                 </a:solidFill>
+                <a:latin typeface="Yu Gothic"/>
+                <a:ea typeface="Yu Gothic"/>
+                <a:cs typeface="Yu Gothic"/>
               </a:defRPr>
             </a:defPPr>
             <a:lvl1pPr>
@@ -4256,6 +4475,9 @@
                 <a:solidFill>
                   <a:srgbClr val="172D42"/>
                 </a:solidFill>
+                <a:latin typeface="Yu Gothic"/>
+                <a:ea typeface="Yu Gothic"/>
+                <a:cs typeface="Yu Gothic"/>
               </a:defRPr>
             </a:lvl1pPr>
             <a:lvl2pPr>
@@ -4263,6 +4485,9 @@
                 <a:solidFill>
                   <a:srgbClr val="172D42"/>
                 </a:solidFill>
+                <a:latin typeface="Yu Gothic"/>
+                <a:ea typeface="Yu Gothic"/>
+                <a:cs typeface="Yu Gothic"/>
               </a:defRPr>
             </a:lvl2pPr>
             <a:lvl3pPr>
@@ -4270,6 +4495,9 @@
                 <a:solidFill>
                   <a:srgbClr val="172D42"/>
                 </a:solidFill>
+                <a:latin typeface="Yu Gothic"/>
+                <a:ea typeface="Yu Gothic"/>
+                <a:cs typeface="Yu Gothic"/>
               </a:defRPr>
             </a:lvl3pPr>
             <a:lvl4pPr>
@@ -4277,6 +4505,9 @@
                 <a:solidFill>
                   <a:srgbClr val="172D42"/>
                 </a:solidFill>
+                <a:latin typeface="Yu Gothic"/>
+                <a:ea typeface="Yu Gothic"/>
+                <a:cs typeface="Yu Gothic"/>
               </a:defRPr>
             </a:lvl4pPr>
             <a:lvl5pPr>
@@ -4284,6 +4515,9 @@
                 <a:solidFill>
                   <a:srgbClr val="172D42"/>
                 </a:solidFill>
+                <a:latin typeface="Yu Gothic"/>
+                <a:ea typeface="Yu Gothic"/>
+                <a:cs typeface="Yu Gothic"/>
               </a:defRPr>
             </a:lvl5pPr>
             <a:lvl6pPr>
@@ -4291,6 +4525,9 @@
                 <a:solidFill>
                   <a:srgbClr val="172D42"/>
                 </a:solidFill>
+                <a:latin typeface="Yu Gothic"/>
+                <a:ea typeface="Yu Gothic"/>
+                <a:cs typeface="Yu Gothic"/>
               </a:defRPr>
             </a:lvl6pPr>
             <a:lvl7pPr>
@@ -4298,6 +4535,9 @@
                 <a:solidFill>
                   <a:srgbClr val="172D42"/>
                 </a:solidFill>
+                <a:latin typeface="Yu Gothic"/>
+                <a:ea typeface="Yu Gothic"/>
+                <a:cs typeface="Yu Gothic"/>
               </a:defRPr>
             </a:lvl7pPr>
             <a:lvl8pPr>
@@ -4305,6 +4545,9 @@
                 <a:solidFill>
                   <a:srgbClr val="172D42"/>
                 </a:solidFill>
+                <a:latin typeface="Yu Gothic"/>
+                <a:ea typeface="Yu Gothic"/>
+                <a:cs typeface="Yu Gothic"/>
               </a:defRPr>
             </a:lvl8pPr>
             <a:lvl9pPr>
@@ -4312,6 +4555,9 @@
                 <a:solidFill>
                   <a:srgbClr val="172D42"/>
                 </a:solidFill>
+                <a:latin typeface="Yu Gothic"/>
+                <a:ea typeface="Yu Gothic"/>
+                <a:cs typeface="Yu Gothic"/>
               </a:defRPr>
             </a:lvl9pPr>
           </a:lstStyle>
@@ -4321,6 +4567,9 @@
                 <a:solidFill>
                   <a:srgbClr val="172D42"/>
                 </a:solidFill>
+                <a:latin typeface="Yu Gothic"/>
+                <a:ea typeface="Yu Gothic"/>
+                <a:cs typeface="Yu Gothic"/>
               </a:defRPr>
             </a:pPr>
             <a:r>
@@ -4328,6 +4577,9 @@
                 <a:solidFill>
                   <a:srgbClr val="172D42"/>
                 </a:solidFill>
+                <a:latin typeface="Yu Gothic"/>
+                <a:ea typeface="Yu Gothic"/>
+                <a:cs typeface="Yu Gothic"/>
               </a:rPr>
               <a:t>デモ＋検索結果でBC</a:t>
             </a:r>
@@ -4339,7 +4591,7 @@
           <p:cNvPr id="9" name="">
             <a:extLst xmlns:a="http://schemas.openxmlformats.org/drawingml/2006/main">
               <a:ext uri="{FF2B5EF4-FFF2-40B4-BE49-F238E27FC236}">
-                <a16:creationId xmlns:a16="http://schemas.microsoft.com/office/drawing/2014/main" id="{94685813-A3DF-43D7-9068-C1917C11CC81}"/>
+                <a16:creationId xmlns:a16="http://schemas.microsoft.com/office/drawing/2014/main" id="{F8648D01-2F60-4A87-9C85-D2B51A10C51F}"/>
               </a:ext>
             </a:extLst>
           </p:cNvPr>
@@ -4369,6 +4621,9 @@
                 <a:solidFill>
                   <a:srgbClr val="66727C"/>
                 </a:solidFill>
+                <a:latin typeface="Yu Gothic"/>
+                <a:ea typeface="Yu Gothic"/>
+                <a:cs typeface="Yu Gothic"/>
               </a:defRPr>
             </a:defPPr>
             <a:lvl1pPr>
@@ -4376,6 +4631,9 @@
                 <a:solidFill>
                   <a:srgbClr val="66727C"/>
                 </a:solidFill>
+                <a:latin typeface="Yu Gothic"/>
+                <a:ea typeface="Yu Gothic"/>
+                <a:cs typeface="Yu Gothic"/>
               </a:defRPr>
             </a:lvl1pPr>
             <a:lvl2pPr>
@@ -4383,6 +4641,9 @@
                 <a:solidFill>
                   <a:srgbClr val="66727C"/>
                 </a:solidFill>
+                <a:latin typeface="Yu Gothic"/>
+                <a:ea typeface="Yu Gothic"/>
+                <a:cs typeface="Yu Gothic"/>
               </a:defRPr>
             </a:lvl2pPr>
             <a:lvl3pPr>
@@ -4390,6 +4651,9 @@
                 <a:solidFill>
                   <a:srgbClr val="66727C"/>
                 </a:solidFill>
+                <a:latin typeface="Yu Gothic"/>
+                <a:ea typeface="Yu Gothic"/>
+                <a:cs typeface="Yu Gothic"/>
               </a:defRPr>
             </a:lvl3pPr>
             <a:lvl4pPr>
@@ -4397,6 +4661,9 @@
                 <a:solidFill>
                   <a:srgbClr val="66727C"/>
                 </a:solidFill>
+                <a:latin typeface="Yu Gothic"/>
+                <a:ea typeface="Yu Gothic"/>
+                <a:cs typeface="Yu Gothic"/>
               </a:defRPr>
             </a:lvl4pPr>
             <a:lvl5pPr>
@@ -4404,6 +4671,9 @@
                 <a:solidFill>
                   <a:srgbClr val="66727C"/>
                 </a:solidFill>
+                <a:latin typeface="Yu Gothic"/>
+                <a:ea typeface="Yu Gothic"/>
+                <a:cs typeface="Yu Gothic"/>
               </a:defRPr>
             </a:lvl5pPr>
             <a:lvl6pPr>
@@ -4411,6 +4681,9 @@
                 <a:solidFill>
                   <a:srgbClr val="66727C"/>
                 </a:solidFill>
+                <a:latin typeface="Yu Gothic"/>
+                <a:ea typeface="Yu Gothic"/>
+                <a:cs typeface="Yu Gothic"/>
               </a:defRPr>
             </a:lvl6pPr>
             <a:lvl7pPr>
@@ -4418,6 +4691,9 @@
                 <a:solidFill>
                   <a:srgbClr val="66727C"/>
                 </a:solidFill>
+                <a:latin typeface="Yu Gothic"/>
+                <a:ea typeface="Yu Gothic"/>
+                <a:cs typeface="Yu Gothic"/>
               </a:defRPr>
             </a:lvl7pPr>
             <a:lvl8pPr>
@@ -4425,6 +4701,9 @@
                 <a:solidFill>
                   <a:srgbClr val="66727C"/>
                 </a:solidFill>
+                <a:latin typeface="Yu Gothic"/>
+                <a:ea typeface="Yu Gothic"/>
+                <a:cs typeface="Yu Gothic"/>
               </a:defRPr>
             </a:lvl8pPr>
             <a:lvl9pPr>
@@ -4432,6 +4711,9 @@
                 <a:solidFill>
                   <a:srgbClr val="66727C"/>
                 </a:solidFill>
+                <a:latin typeface="Yu Gothic"/>
+                <a:ea typeface="Yu Gothic"/>
+                <a:cs typeface="Yu Gothic"/>
               </a:defRPr>
             </a:lvl9pPr>
           </a:lstStyle>
@@ -4441,6 +4723,9 @@
                 <a:solidFill>
                   <a:srgbClr val="66727C"/>
                 </a:solidFill>
+                <a:latin typeface="Yu Gothic"/>
+                <a:ea typeface="Yu Gothic"/>
+                <a:cs typeface="Yu Gothic"/>
               </a:defRPr>
             </a:pPr>
             <a:r>
@@ -4448,6 +4733,9 @@
                 <a:solidFill>
                   <a:srgbClr val="66727C"/>
                 </a:solidFill>
+                <a:latin typeface="Yu Gothic"/>
+                <a:ea typeface="Yu Gothic"/>
+                <a:cs typeface="Yu Gothic"/>
               </a:rPr>
               <a:t>Du et al., 2023  Fig. 2 / §III</a:t>
             </a:r>
@@ -4457,7 +4745,7 @@
     </p:spTree>
     <p:extLst>
       <p:ext uri="{BB962C8B-B14F-4D97-AF65-F5344CB8AC3E}">
-        <p14:creationId xmlns:p14="http://schemas.microsoft.com/office/powerpoint/2010/main" val="1222381756"/>
+        <p14:creationId xmlns:p14="http://schemas.microsoft.com/office/powerpoint/2010/main" val="1682406682"/>
       </p:ext>
     </p:extLst>
   </p:cSld>

</xml_diff>